<commit_message>
Add phone mode: use a phone as the camera over local HTTPS
python -m drishti --phone serves the page on the local network over
HTTPS with a certificate generated on the machine, because phone
browsers only allow camera access on secure pages. The default stays
loopback-only. On phones the camera picture is a large Describe button,
the result sits directly under it, the phone vibrates on a warning, and
audio is unlocked on the first touch.
</commit_message>
<xml_diff>
--- a/docs/DrishtiAI-pitch.pptx
+++ b/docs/DrishtiAI-pitch.pptx
@@ -4,6 +4,9 @@
   <p:sldMasterIdLst>
     <p:sldMasterId id="2147483648" r:id="rId1"/>
   </p:sldMasterIdLst>
+  <p:notesMasterIdLst>
+    <p:notesMasterId r:id="rId9"/>
+  </p:notesMasterIdLst>
   <p:sldIdLst>
     <p:sldId id="256" r:id="rId2"/>
     <p:sldId id="257" r:id="rId3"/>
@@ -13,10 +16,7 @@
     <p:sldId id="261" r:id="rId7"/>
     <p:sldId id="262" r:id="rId8"/>
   </p:sldIdLst>
-  <p:notesMasterIdLst>
-    <p:notesMasterId r:id="rId9"/>
-  </p:notesMasterIdLst>
-  <p:sldSz cx="9144000" cy="5143500"/>
+  <p:sldSz cx="9144000" cy="5143500" type="screen16x9"/>
   <p:notesSz cx="5143500" cy="9144000"/>
   <p:defaultTextStyle>
     <a:lvl1pPr marL="0" algn="l" defTabSz="914400" rtl="0" eaLnBrk="1" latinLnBrk="0" hangingPunct="1">
@@ -113,25 +113,25 @@
   <p:extLst>
     <p:ext uri="{521415D9-36F7-43E2-AB2F-B90AF26B5E84}">
       <p14:sectionLst xmlns:p14="http://schemas.microsoft.com/office/powerpoint/2010/main">
-        <p14:section name="Introduction" id="{48d74bae-7a29-9241-b334-107871ab055a}">
+        <p14:section name="Introduction" id="{48D74BAE-7A29-9241-B334-107871AB055A}">
           <p14:sldIdLst>
             <p14:sldId id="256"/>
             <p14:sldId id="257"/>
           </p14:sldIdLst>
         </p14:section>
-        <p14:section name="Product" id="{9e899b54-b9e8-5181-42de-604de834d96e}">
+        <p14:section name="Product" id="{9E899B54-B9E8-5181-42DE-604DE834D96E}">
           <p14:sldIdLst>
             <p14:sldId id="258"/>
             <p14:sldId id="259"/>
           </p14:sldIdLst>
         </p14:section>
-        <p14:section name="Evidence" id="{364a6735-38a6-682d-cb5b-b689de537891}">
+        <p14:section name="Evidence" id="{364A6735-38A6-682D-CB5B-B689DE537891}">
           <p14:sldIdLst>
             <p14:sldId id="260"/>
             <p14:sldId id="261"/>
           </p14:sldIdLst>
         </p14:section>
-        <p14:section name="Close" id="{d05e25b6-a44c-17ae-e999-3a0f30d7e650}">
+        <p14:section name="Close" id="{D05E25B6-A44C-17AE-E999-3A0F30D7E650}">
           <p14:sldIdLst>
             <p14:sldId id="262"/>
           </p14:sldIdLst>
@@ -145,10 +145,41 @@
 </p:presentation>
 </file>
 
+<file path=ppt/changesInfos/changesInfo1.xml><?xml version="1.0" encoding="utf-8"?>
+<pc:chgInfo xmlns:a="http://schemas.openxmlformats.org/drawingml/2006/main" xmlns:r="http://schemas.openxmlformats.org/officeDocument/2006/relationships" xmlns:ac="http://schemas.microsoft.com/office/drawing/2013/main/command" xmlns:pc="http://schemas.microsoft.com/office/powerpoint/2013/main/command">
+  <pc:docChgLst>
+    <pc:chgData name="daksh wadhwa" userId="04cf032a23d35f2b" providerId="LiveId" clId="{40ED15CA-B7FC-4858-B3E8-4D2301031031}"/>
+    <pc:docChg chg="modSld">
+      <pc:chgData name="daksh wadhwa" userId="04cf032a23d35f2b" providerId="LiveId" clId="{40ED15CA-B7FC-4858-B3E8-4D2301031031}" dt="2026-10-11T12:00:34.448" v="14" actId="20577"/>
+      <pc:docMkLst>
+        <pc:docMk/>
+      </pc:docMkLst>
+      <pc:sldChg chg="modSp mod">
+        <pc:chgData name="daksh wadhwa" userId="04cf032a23d35f2b" providerId="LiveId" clId="{40ED15CA-B7FC-4858-B3E8-4D2301031031}" dt="2026-10-11T12:00:34.448" v="14" actId="20577"/>
+        <pc:sldMkLst>
+          <pc:docMk/>
+          <pc:sldMk cId="0" sldId="256"/>
+        </pc:sldMkLst>
+        <pc:spChg chg="mod">
+          <ac:chgData name="daksh wadhwa" userId="04cf032a23d35f2b" providerId="LiveId" clId="{40ED15CA-B7FC-4858-B3E8-4D2301031031}" dt="2026-10-11T12:00:34.448" v="14" actId="20577"/>
+          <ac:spMkLst>
+            <pc:docMk/>
+            <pc:sldMk cId="0" sldId="256"/>
+            <ac:spMk id="4" creationId="{00000000-0000-0000-0000-000000000000}"/>
+          </ac:spMkLst>
+        </pc:spChg>
+      </pc:sldChg>
+    </pc:docChg>
+  </pc:docChgLst>
+</pc:chgInfo>
+</file>
+
 <file path=ppt/charts/chart1.xml><?xml version="1.0" encoding="utf-8"?>
-<c:chartSpace xmlns:c="http://schemas.openxmlformats.org/drawingml/2006/chart" xmlns:a="http://schemas.openxmlformats.org/drawingml/2006/main" xmlns:r="http://schemas.openxmlformats.org/officeDocument/2006/relationships">
+<c:chartSpace xmlns:c="http://schemas.openxmlformats.org/drawingml/2006/chart" xmlns:a="http://schemas.openxmlformats.org/drawingml/2006/main" xmlns:r="http://schemas.openxmlformats.org/officeDocument/2006/relationships" xmlns:c16r2="http://schemas.microsoft.com/office/drawing/2015/06/chart">
   <c:date1904 val="0"/>
+  <c:lang val="en-US"/>
   <c:roundedCorners val="1"/>
+  <c:style val="2"/>
   <c:chart>
     <c:autoTitleDeleted val="1"/>
     <c:plotArea>
@@ -180,18 +211,26 @@
           <c:invertIfNegative val="0"/>
           <c:dLbls>
             <c:numFmt formatCode="#,##0" sourceLinked="0"/>
+            <c:spPr>
+              <a:noFill/>
+              <a:ln>
+                <a:noFill/>
+              </a:ln>
+              <a:effectLst/>
+            </c:spPr>
             <c:txPr>
               <a:bodyPr/>
               <a:lstStyle/>
               <a:p>
                 <a:pPr>
-                  <a:defRPr b="0" i="0" strike="noStrike" sz="1200" u="none">
+                  <a:defRPr sz="1200" b="0" i="0" u="none" strike="noStrike">
                     <a:solidFill>
                       <a:srgbClr val="FFFFFF"/>
                     </a:solidFill>
                     <a:latin typeface="+mn-lt"/>
                   </a:defRPr>
                 </a:pPr>
+                <a:endParaRPr lang="en-US"/>
               </a:p>
             </c:txPr>
             <c:showLegendKey val="0"/>
@@ -201,25 +240,28 @@
             <c:showPercent val="0"/>
             <c:showBubbleSize val="0"/>
             <c:showLeaderLines val="0"/>
+            <c:extLst>
+              <c:ext xmlns:c15="http://schemas.microsoft.com/office/drawing/2012/chart" uri="{CE6537A1-D6FC-4f65-9D91-7224C49458BB}">
+                <c15:showLeaderLines val="0"/>
+              </c:ext>
+            </c:extLst>
           </c:dLbls>
           <c:cat>
-            <c:multiLvlStrRef>
+            <c:strRef>
               <c:f>Sheet1!$A$2:$A$4</c:f>
-              <c:multiLvlStrCache>
+              <c:strCache>
                 <c:ptCount val="3"/>
-                <c:lvl>
-                  <c:pt idx="0">
-                    <c:v>Hazards found (of 15)</c:v>
-                  </c:pt>
-                  <c:pt idx="1">
-                    <c:v>Missed hazards</c:v>
-                  </c:pt>
-                  <c:pt idx="2">
-                    <c:v>False alarms</c:v>
-                  </c:pt>
-                </c:lvl>
-              </c:multiLvlStrCache>
-            </c:multiLvlStrRef>
+                <c:pt idx="0">
+                  <c:v>Hazards found (of 15)</c:v>
+                </c:pt>
+                <c:pt idx="1">
+                  <c:v>Missed hazards</c:v>
+                </c:pt>
+                <c:pt idx="2">
+                  <c:v>False alarms</c:v>
+                </c:pt>
+              </c:strCache>
+            </c:strRef>
           </c:cat>
           <c:val>
             <c:numRef>
@@ -239,6 +281,11 @@
               </c:numCache>
             </c:numRef>
           </c:val>
+          <c:extLst>
+            <c:ext xmlns:c16="http://schemas.microsoft.com/office/drawing/2014/chart" uri="{C3380CC4-5D6E-409C-BE32-E72D297353CC}">
+              <c16:uniqueId val="{00000000-BC46-4898-A9DB-F9300D8327A8}"/>
+            </c:ext>
+          </c:extLst>
         </c:ser>
         <c:ser>
           <c:idx val="1"/>
@@ -263,18 +310,26 @@
           <c:invertIfNegative val="0"/>
           <c:dLbls>
             <c:numFmt formatCode="#,##0" sourceLinked="0"/>
+            <c:spPr>
+              <a:noFill/>
+              <a:ln>
+                <a:noFill/>
+              </a:ln>
+              <a:effectLst/>
+            </c:spPr>
             <c:txPr>
               <a:bodyPr/>
               <a:lstStyle/>
               <a:p>
                 <a:pPr>
-                  <a:defRPr b="0" i="0" strike="noStrike" sz="1200" u="none">
+                  <a:defRPr sz="1200" b="0" i="0" u="none" strike="noStrike">
                     <a:solidFill>
                       <a:srgbClr val="FFFFFF"/>
                     </a:solidFill>
                     <a:latin typeface="+mn-lt"/>
                   </a:defRPr>
                 </a:pPr>
+                <a:endParaRPr lang="en-US"/>
               </a:p>
             </c:txPr>
             <c:showLegendKey val="0"/>
@@ -284,25 +339,28 @@
             <c:showPercent val="0"/>
             <c:showBubbleSize val="0"/>
             <c:showLeaderLines val="0"/>
+            <c:extLst>
+              <c:ext xmlns:c15="http://schemas.microsoft.com/office/drawing/2012/chart" uri="{CE6537A1-D6FC-4f65-9D91-7224C49458BB}">
+                <c15:showLeaderLines val="0"/>
+              </c:ext>
+            </c:extLst>
           </c:dLbls>
           <c:cat>
-            <c:multiLvlStrRef>
+            <c:strRef>
               <c:f>Sheet1!$A$2:$A$4</c:f>
-              <c:multiLvlStrCache>
+              <c:strCache>
                 <c:ptCount val="3"/>
-                <c:lvl>
-                  <c:pt idx="0">
-                    <c:v>Hazards found (of 15)</c:v>
-                  </c:pt>
-                  <c:pt idx="1">
-                    <c:v>Missed hazards</c:v>
-                  </c:pt>
-                  <c:pt idx="2">
-                    <c:v>False alarms</c:v>
-                  </c:pt>
-                </c:lvl>
-              </c:multiLvlStrCache>
-            </c:multiLvlStrRef>
+                <c:pt idx="0">
+                  <c:v>Hazards found (of 15)</c:v>
+                </c:pt>
+                <c:pt idx="1">
+                  <c:v>Missed hazards</c:v>
+                </c:pt>
+                <c:pt idx="2">
+                  <c:v>False alarms</c:v>
+                </c:pt>
+              </c:strCache>
+            </c:strRef>
           </c:cat>
           <c:val>
             <c:numRef>
@@ -322,36 +380,23 @@
               </c:numCache>
             </c:numRef>
           </c:val>
+          <c:extLst>
+            <c:ext xmlns:c16="http://schemas.microsoft.com/office/drawing/2014/chart" uri="{C3380CC4-5D6E-409C-BE32-E72D297353CC}">
+              <c16:uniqueId val="{00000001-BC46-4898-A9DB-F9300D8327A8}"/>
+            </c:ext>
+          </c:extLst>
         </c:ser>
         <c:dLbls>
-          <c:numFmt formatCode="#,##0" sourceLinked="0"/>
-          <c:txPr>
-            <a:bodyPr/>
-            <a:lstStyle/>
-            <a:p>
-              <a:pPr>
-                <a:defRPr b="0" i="0" strike="noStrike" sz="1200" u="none">
-                  <a:solidFill>
-                    <a:srgbClr val="FFFFFF"/>
-                  </a:solidFill>
-                  <a:latin typeface="+mn-lt"/>
-                </a:defRPr>
-              </a:pPr>
-            </a:p>
-          </c:txPr>
           <c:showLegendKey val="0"/>
           <c:showVal val="1"/>
           <c:showCatName val="0"/>
           <c:showSerName val="0"/>
           <c:showPercent val="0"/>
           <c:showBubbleSize val="0"/>
-          <c:showLeaderLines val="0"/>
         </c:dLbls>
         <c:gapWidth val="60"/>
-        <c:overlap val="0"/>
         <c:axId val="2094734554"/>
         <c:axId val="2094734552"/>
-        <c:axId val="2094734556"/>
       </c:barChart>
       <c:catAx>
         <c:axId val="2094734554"/>
@@ -392,6 +437,7 @@
         <c:crosses val="autoZero"/>
         <c:auto val="1"/>
         <c:lblAlgn val="ctr"/>
+        <c:lblOffset val="100"/>
         <c:noMultiLvlLbl val="1"/>
       </c:catAx>
       <c:valAx>
@@ -405,30 +451,6 @@
         <c:majorTickMark val="out"/>
         <c:minorTickMark val="none"/>
         <c:tickLblPos val="nextTo"/>
-        <c:spPr>
-          <a:ln w="12700" cap="flat">
-            <a:solidFill>
-              <a:srgbClr val="888888"/>
-            </a:solidFill>
-            <a:prstDash val="solid"/>
-            <a:round/>
-          </a:ln>
-        </c:spPr>
-        <c:txPr>
-          <a:bodyPr/>
-          <a:lstStyle/>
-          <a:p>
-            <a:pPr>
-              <a:defRPr sz="1200" b="0" i="0" u="none" strike="noStrike">
-                <a:solidFill>
-                  <a:srgbClr val="000000"/>
-                </a:solidFill>
-                <a:latin typeface="Arial"/>
-              </a:defRPr>
-            </a:pPr>
-            <a:endParaRPr lang="en-US"/>
-          </a:p>
-        </c:txPr>
         <c:crossAx val="2094734554"/>
         <c:crosses val="autoZero"/>
         <c:crossBetween val="between"/>
@@ -463,6 +485,7 @@
     </c:legend>
     <c:plotVisOnly val="1"/>
     <c:dispBlanksAs val="span"/>
+    <c:showDLblsOverMax val="1"/>
   </c:chart>
   <c:spPr>
     <a:noFill/>
@@ -499,234 +522,10 @@
           <a:chExt cx="0" cy="0"/>
         </a:xfrm>
       </p:grpSpPr>
-      <p:sp>
-        <p:nvSpPr>
-          <p:cNvPr id="2" name="Header Placeholder 1"/>
-          <p:cNvSpPr>
-            <a:spLocks noGrp="1"/>
-          </p:cNvSpPr>
-          <p:nvPr>
-            <p:ph type="hdr" sz="quarter"/>
-          </p:nvPr>
-        </p:nvSpPr>
-        <p:spPr>
-          <a:xfrm>
-            <a:off x="0" y="0"/>
-            <a:ext cx="2971800" cy="458788"/>
-          </a:xfrm>
-          <a:prstGeom prst="rect">
-            <a:avLst/>
-          </a:prstGeom>
-        </p:spPr>
-        <p:txBody>
-          <a:bodyPr vert="horz" lIns="91440" tIns="45720" rIns="91440" bIns="45720" rtlCol="0"/>
-          <a:lstStyle>
-            <a:lvl1pPr algn="l">
-              <a:defRPr sz="1200"/>
-            </a:lvl1pPr>
-          </a:lstStyle>
-          <a:p>
-            <a:endParaRPr lang="en-US"/>
-          </a:p>
-        </p:txBody>
-      </p:sp>
-      <p:sp>
-        <p:nvSpPr>
-          <p:cNvPr id="3" name="Date Placeholder 2"/>
-          <p:cNvSpPr>
-            <a:spLocks noGrp="1"/>
-          </p:cNvSpPr>
-          <p:nvPr>
-            <p:ph type="dt" idx="1"/>
-          </p:nvPr>
-        </p:nvSpPr>
-        <p:spPr>
-          <a:xfrm>
-            <a:off x="3884613" y="0"/>
-            <a:ext cx="2971800" cy="458788"/>
-          </a:xfrm>
-          <a:prstGeom prst="rect">
-            <a:avLst/>
-          </a:prstGeom>
-        </p:spPr>
-        <p:txBody>
-          <a:bodyPr vert="horz" lIns="91440" tIns="45720" rIns="91440" bIns="45720" rtlCol="0"/>
-          <a:lstStyle>
-            <a:lvl1pPr algn="r">
-              <a:defRPr sz="1200"/>
-            </a:lvl1pPr>
-          </a:lstStyle>
-          <a:p>
-            <a:fld id="{5282F153-3F37-0F45-9E97-73ACFA13230C}" type="datetimeFigureOut">
-              <a:rPr lang="en-US"/>
-              <a:t>7/23/19</a:t>
-            </a:fld>
-            <a:endParaRPr lang="en-US"/>
-          </a:p>
-        </p:txBody>
-      </p:sp>
-      <p:sp>
-        <p:nvSpPr>
-          <p:cNvPr id="4" name="Slide Image Placeholder 3"/>
-          <p:cNvSpPr>
-            <a:spLocks noGrp="1" noRot="1" noChangeAspect="1"/>
-          </p:cNvSpPr>
-          <p:nvPr>
-            <p:ph type="sldImg" idx="2"/>
-          </p:nvPr>
-        </p:nvSpPr>
-        <p:spPr>
-          <a:xfrm>
-            <a:off x="685800" y="1143000"/>
-            <a:ext cx="5486400" cy="3086100"/>
-          </a:xfrm>
-          <a:prstGeom prst="rect">
-            <a:avLst/>
-          </a:prstGeom>
-          <a:noFill/>
-          <a:ln w="12700">
-            <a:solidFill>
-              <a:prstClr val="black"/>
-            </a:solidFill>
-          </a:ln>
-        </p:spPr>
-        <p:txBody>
-          <a:bodyPr vert="horz" lIns="91440" tIns="45720" rIns="91440" bIns="45720" rtlCol="0" anchor="ctr"/>
-          <a:lstStyle/>
-          <a:p>
-            <a:endParaRPr lang="en-US"/>
-          </a:p>
-        </p:txBody>
-      </p:sp>
-      <p:sp>
-        <p:nvSpPr>
-          <p:cNvPr id="5" name="Notes Placeholder 4"/>
-          <p:cNvSpPr>
-            <a:spLocks noGrp="1"/>
-          </p:cNvSpPr>
-          <p:nvPr>
-            <p:ph type="body" sz="quarter" idx="3"/>
-          </p:nvPr>
-        </p:nvSpPr>
-        <p:spPr>
-          <a:xfrm>
-            <a:off x="685800" y="4400550"/>
-            <a:ext cx="5486400" cy="3600450"/>
-          </a:xfrm>
-          <a:prstGeom prst="rect">
-            <a:avLst/>
-          </a:prstGeom>
-        </p:spPr>
-        <p:txBody>
-          <a:bodyPr vert="horz" lIns="91440" tIns="45720" rIns="91440" bIns="45720" rtlCol="0"/>
-          <a:lstStyle/>
-          <a:p>
-            <a:pPr lvl="0"/>
-            <a:r>
-              <a:rPr lang="en-US"/>
-              <a:t>Click to edit Master text styles</a:t>
-            </a:r>
-          </a:p>
-          <a:p>
-            <a:pPr lvl="1"/>
-            <a:r>
-              <a:rPr lang="en-US"/>
-              <a:t>Second level</a:t>
-            </a:r>
-          </a:p>
-          <a:p>
-            <a:pPr lvl="2"/>
-            <a:r>
-              <a:rPr lang="en-US"/>
-              <a:t>Third level</a:t>
-            </a:r>
-          </a:p>
-          <a:p>
-            <a:pPr lvl="3"/>
-            <a:r>
-              <a:rPr lang="en-US"/>
-              <a:t>Fourth level</a:t>
-            </a:r>
-          </a:p>
-          <a:p>
-            <a:pPr lvl="4"/>
-            <a:r>
-              <a:rPr lang="en-US"/>
-              <a:t>Fifth level</a:t>
-            </a:r>
-          </a:p>
-        </p:txBody>
-      </p:sp>
-      <p:sp>
-        <p:nvSpPr>
-          <p:cNvPr id="6" name="Footer Placeholder 5"/>
-          <p:cNvSpPr>
-            <a:spLocks noGrp="1"/>
-          </p:cNvSpPr>
-          <p:nvPr>
-            <p:ph type="ftr" sz="quarter" idx="4"/>
-          </p:nvPr>
-        </p:nvSpPr>
-        <p:spPr>
-          <a:xfrm>
-            <a:off x="0" y="8685213"/>
-            <a:ext cx="2971800" cy="458787"/>
-          </a:xfrm>
-          <a:prstGeom prst="rect">
-            <a:avLst/>
-          </a:prstGeom>
-        </p:spPr>
-        <p:txBody>
-          <a:bodyPr vert="horz" lIns="91440" tIns="45720" rIns="91440" bIns="45720" rtlCol="0" anchor="b"/>
-          <a:lstStyle>
-            <a:lvl1pPr algn="l">
-              <a:defRPr sz="1200"/>
-            </a:lvl1pPr>
-          </a:lstStyle>
-          <a:p>
-            <a:endParaRPr lang="en-US"/>
-          </a:p>
-        </p:txBody>
-      </p:sp>
-      <p:sp>
-        <p:nvSpPr>
-          <p:cNvPr id="7" name="Slide Number Placeholder 6"/>
-          <p:cNvSpPr>
-            <a:spLocks noGrp="1"/>
-          </p:cNvSpPr>
-          <p:nvPr>
-            <p:ph type="sldNum" sz="quarter" idx="5"/>
-          </p:nvPr>
-        </p:nvSpPr>
-        <p:spPr>
-          <a:xfrm>
-            <a:off x="3884613" y="8685213"/>
-            <a:ext cx="2971800" cy="458787"/>
-          </a:xfrm>
-          <a:prstGeom prst="rect">
-            <a:avLst/>
-          </a:prstGeom>
-        </p:spPr>
-        <p:txBody>
-          <a:bodyPr vert="horz" lIns="91440" tIns="45720" rIns="91440" bIns="45720" rtlCol="0" anchor="b"/>
-          <a:lstStyle>
-            <a:lvl1pPr algn="r">
-              <a:defRPr sz="1200"/>
-            </a:lvl1pPr>
-          </a:lstStyle>
-          <a:p>
-            <a:fld id="{CE5E9CC1-C706-0F49-92D6-E571CC5EEA8F}" type="slidenum">
-              <a:rPr lang="en-US"/>
-              <a:t>‹#›</a:t>
-            </a:fld>
-            <a:endParaRPr lang="en-US"/>
-          </a:p>
-        </p:txBody>
-      </p:sp>
     </p:spTree>
     <p:extLst>
       <p:ext uri="{BB962C8B-B14F-4D97-AF65-F5344CB8AC3E}">
-        <p14:creationId xmlns:p14="http://schemas.microsoft.com/office/powerpoint/2010/main" val="1024086991"/>
+        <p14:creationId xmlns:p14="http://schemas.microsoft.com/office/powerpoint/2010/main" val="2179979258"/>
       </p:ext>
     </p:extLst>
   </p:cSld>
@@ -874,7 +673,6 @@
               <a:rPr lang="en-US" dirty="0"/>
               <a:t>DrishtiAI describes what is in front of a blind or low-vision person. It runs entirely on this laptop: an open-weight vision model, no cloud. Drishti is Hindi for sight. I will show the problem, a live demo, how it works, and what the evaluation found, including what it gets wrong.</a:t>
             </a:r>
-            <a:endParaRPr lang="en-US" dirty="0"/>
           </a:p>
         </p:txBody>
       </p:sp>
@@ -962,7 +760,6 @@
               <a:rPr lang="en-US" dirty="0"/>
               <a:t>Most scene-description apps send every camera frame to a server. That is a privacy problem, it fails without signal, and it costs money per image. The question for today: how far can a small open model on one laptop get?</a:t>
             </a:r>
-            <a:endParaRPr lang="en-US" dirty="0"/>
           </a:p>
         </p:txBody>
       </p:sp>
@@ -1050,7 +847,6 @@
               <a:rPr lang="en-US" dirty="0"/>
               <a:t>DEMO HERE. Wi-Fi is off. Press Space on a scene with something in the way: it warns first, then describes. Press 2 and hold up a printed label. Press 3, type water bottle, press Enter. Press L to hear the same answer in Hindi. The whole page works from the keyboard.</a:t>
             </a:r>
-            <a:endParaRPr lang="en-US" dirty="0"/>
           </a:p>
         </p:txBody>
       </p:sp>
@@ -1138,7 +934,6 @@
               <a:rPr lang="en-US" dirty="0"/>
               <a:t>A frame goes to FastAPI on this machine, then to Qwen3-VL through Ollama. The model must return strict JSON. If it does not validate, it is asked once more, and after that the answer is marked as rough: hazards are never invented to fill a gap. A separate speech layer decides what is said, always hazards first. The same function is packaged as an Agent Skill.</a:t>
             </a:r>
-            <a:endParaRPr lang="en-US" dirty="0"/>
           </a:p>
         </p:txBody>
       </p:sp>
@@ -1226,7 +1021,6 @@
               <a:rPr lang="en-US" dirty="0"/>
               <a:t>30 fixed images: 21 openly licensed photos and 9 rendered text images. Missed hazards are counted on their own because that is the dangerous failure. The first real run was poor: 9 of 15 found and 31 false alarms. After one prompt change it found 14 of 15 with 6 false alarms. Be upfront: I tuned on this same set, so this is optimistic, and it still over-warns on clear scenes. Both result files are in the repository.</a:t>
             </a:r>
-            <a:endParaRPr lang="en-US" dirty="0"/>
           </a:p>
         </p:txBody>
       </p:sp>
@@ -1314,7 +1108,6 @@
               <a:rPr lang="en-US" dirty="0"/>
               <a:t>Nothing worked the first time, and each failure is documented. The plain model tag was a thinking variant that never produced an answer. The model then parroted my own example hazards back at me. And it cannot write Hindi, so Hindi warnings come from a fixed glossary: correct and predictable, but it drops adjectives.</a:t>
             </a:r>
-            <a:endParaRPr lang="en-US" dirty="0"/>
           </a:p>
         </p:txBody>
       </p:sp>
@@ -1402,7 +1195,6 @@
               <a:rPr lang="en-US" dirty="0"/>
               <a:t>It is an experimental aid, not a safety device. It over-warns, it takes four to five seconds end to end, and it misreads small text. Next I would build a held-out test set, try a larger multilingual model for real Hindi, and add voice input. Everything is in the repository: MIT code, an Apache-2.0 model, the evaluation, the tests and the Agent Skill.</a:t>
             </a:r>
-            <a:endParaRPr lang="en-US" dirty="0"/>
           </a:p>
         </p:txBody>
       </p:sp>
@@ -1480,6 +1272,7 @@
         <a:solidFill>
           <a:srgbClr val="0B0B0B"/>
         </a:solidFill>
+        <a:effectLst/>
       </p:bgPr>
     </p:bg>
     <p:spTree>
@@ -1499,9 +1292,11 @@
       <p:sp>
         <p:nvSpPr>
           <p:cNvPr id="2" name="Text 0"/>
-          <p:cNvSpPr/>
+          <p:cNvSpPr>
+            <a:spLocks noGrp="1"/>
+          </p:cNvSpPr>
           <p:nvPr>
-            <p:ph idx="100" type="title" hasCustomPrompt="1"/>
+            <p:ph type="title" idx="100" hasCustomPrompt="1"/>
           </p:nvPr>
         </p:nvSpPr>
         <p:spPr>
@@ -1518,7 +1313,7 @@
         <p:txBody>
           <a:bodyPr wrap="square" rtlCol="0"/>
           <a:lstStyle>
-            <a:lvl1pPr algn="l" indent="0" marL="0">
+            <a:lvl1pPr marL="0" indent="0" algn="l">
               <a:buNone/>
               <a:defRPr lang="en-US" sz="5400" b="1" dirty="0">
                 <a:solidFill>
@@ -1528,7 +1323,7 @@
             </a:lvl1pPr>
           </a:lstStyle>
           <a:p>
-            <a:pPr algn="l" indent="0" marL="0">
+            <a:pPr marL="0" indent="0" algn="l">
               <a:buNone/>
             </a:pPr>
             <a:endParaRPr lang="en-US" sz="5400" dirty="0"/>
@@ -1538,9 +1333,11 @@
       <p:sp>
         <p:nvSpPr>
           <p:cNvPr id="3" name="Text 0"/>
-          <p:cNvSpPr/>
+          <p:cNvSpPr>
+            <a:spLocks noGrp="1"/>
+          </p:cNvSpPr>
           <p:nvPr>
-            <p:ph idx="101" type="body" hasCustomPrompt="1"/>
+            <p:ph type="body" idx="101" hasCustomPrompt="1"/>
           </p:nvPr>
         </p:nvSpPr>
         <p:spPr>
@@ -1557,7 +1354,7 @@
         <p:txBody>
           <a:bodyPr wrap="square" rtlCol="0"/>
           <a:lstStyle>
-            <a:lvl1pPr algn="l" indent="0" marL="0">
+            <a:lvl1pPr marL="0" indent="0" algn="l">
               <a:buNone/>
               <a:defRPr lang="en-US" sz="1800" dirty="0">
                 <a:solidFill>
@@ -1567,7 +1364,7 @@
             </a:lvl1pPr>
           </a:lstStyle>
           <a:p>
-            <a:pPr algn="l" indent="0" marL="0">
+            <a:pPr marL="0" indent="0" algn="l">
               <a:buNone/>
             </a:pPr>
             <a:endParaRPr lang="en-US" sz="1800" dirty="0"/>
@@ -1590,6 +1387,7 @@
         <a:solidFill>
           <a:srgbClr val="0B0B0B"/>
         </a:solidFill>
+        <a:effectLst/>
       </p:bgPr>
     </p:bg>
     <p:spTree>
@@ -1609,9 +1407,11 @@
       <p:sp>
         <p:nvSpPr>
           <p:cNvPr id="2" name="Text 0"/>
-          <p:cNvSpPr/>
+          <p:cNvSpPr>
+            <a:spLocks noGrp="1"/>
+          </p:cNvSpPr>
           <p:nvPr>
-            <p:ph idx="100" type="title" hasCustomPrompt="1"/>
+            <p:ph type="title" idx="100" hasCustomPrompt="1"/>
           </p:nvPr>
         </p:nvSpPr>
         <p:spPr>
@@ -1628,7 +1428,7 @@
         <p:txBody>
           <a:bodyPr wrap="square" rtlCol="0"/>
           <a:lstStyle>
-            <a:lvl1pPr algn="l" indent="0" marL="0">
+            <a:lvl1pPr marL="0" indent="0" algn="l">
               <a:buNone/>
               <a:defRPr lang="en-US" sz="2800" b="1" dirty="0">
                 <a:solidFill>
@@ -1638,7 +1438,7 @@
             </a:lvl1pPr>
           </a:lstStyle>
           <a:p>
-            <a:pPr algn="l" indent="0" marL="0">
+            <a:pPr marL="0" indent="0" algn="l">
               <a:buNone/>
             </a:pPr>
             <a:endParaRPr lang="en-US" sz="2800" dirty="0"/>
@@ -1666,7 +1466,7 @@
           <a:bodyPr wrap="square" lIns="0" tIns="0" rIns="0" bIns="0" rtlCol="0" anchor="ctr"/>
           <a:lstStyle/>
           <a:p>
-            <a:pPr indent="0" marL="0">
+            <a:pPr marL="0" indent="0">
               <a:buNone/>
             </a:pPr>
             <a:r>
@@ -1701,7 +1501,7 @@
           </a:prstGeom>
           <a:extLst>
             <a:ext uri="{C572A759-6A51-4108-AA02-DFA0A04FC94B}">
-              <ma14:wrappingTextBoxFlag xmlns:ma14="http://schemas.microsoft.com/office/mac/drawingml/2011/main" val="0"/>
+              <ma14:wrappingTextBoxFlag xmlns:ma14="http://schemas.microsoft.com/office/mac/drawingml/2011/main" xmlns="" val="0"/>
             </a:ext>
           </a:extLst>
         </p:spPr>
@@ -1719,8 +1519,8 @@
           <a:p>
             <a:pPr algn="r"/>
             <a:fld id="{F7021451-1387-4CA6-816F-3879F97B5CBC}" type="slidenum">
-              <a:rPr b="0" lang="en-US"/>
-              <a:t>1003</a:t>
+              <a:rPr lang="en-US" b="0"/>
+              <a:t>‹#›</a:t>
             </a:fld>
             <a:endParaRPr lang="en-US"/>
           </a:p>
@@ -1737,6 +1537,11 @@
 <file path=ppt/slideMasters/slideMaster1.xml><?xml version="1.0" encoding="utf-8"?>
 <p:sldMaster xmlns:a="http://schemas.openxmlformats.org/drawingml/2006/main" xmlns:r="http://schemas.openxmlformats.org/officeDocument/2006/relationships" xmlns:p="http://schemas.openxmlformats.org/presentationml/2006/main">
   <p:cSld>
+    <p:bg>
+      <p:bgRef idx="1001">
+        <a:schemeClr val="bg1"/>
+      </p:bgRef>
+    </p:bg>
     <p:spTree>
       <p:nvGrpSpPr>
         <p:cNvPr id="1" name=""/>
@@ -1771,7 +1576,7 @@
           </a:prstGeom>
           <a:extLst>
             <a:ext uri="{C572A759-6A51-4108-AA02-DFA0A04FC94B}">
-              <ma14:wrappingTextBoxFlag xmlns:ma14="http://schemas.microsoft.com/office/mac/drawingml/2011/main" val="0"/>
+              <ma14:wrappingTextBoxFlag xmlns:ma14="http://schemas.microsoft.com/office/mac/drawingml/2011/main" xmlns="" val="0"/>
             </a:ext>
           </a:extLst>
         </p:spPr>
@@ -1789,8 +1594,8 @@
           <a:p>
             <a:pPr algn="r"/>
             <a:fld id="{F7021451-1387-4CA6-816F-3879F97B5CBC}" type="slidenum">
-              <a:rPr b="0" lang="en-US"/>
-              <a:t>null</a:t>
+              <a:rPr lang="en-US" b="0"/>
+              <a:t>‹#›</a:t>
             </a:fld>
             <a:endParaRPr lang="en-US"/>
           </a:p>
@@ -2078,9 +1883,11 @@
       <p:sp>
         <p:nvSpPr>
           <p:cNvPr id="2" name="Text 0"/>
-          <p:cNvSpPr/>
+          <p:cNvSpPr>
+            <a:spLocks noGrp="1"/>
+          </p:cNvSpPr>
           <p:nvPr>
-            <p:ph idx="100" type="title" hasCustomPrompt="1"/>
+            <p:ph type="title" idx="100" hasCustomPrompt="1"/>
           </p:nvPr>
         </p:nvSpPr>
         <p:spPr>
@@ -2098,7 +1905,7 @@
           <a:bodyPr wrap="square" lIns="0" tIns="0" rIns="0" bIns="0" rtlCol="0" anchor="t"/>
           <a:lstStyle/>
           <a:p>
-            <a:pPr algn="l" indent="0" marL="0">
+            <a:pPr marL="0" indent="0" algn="l">
               <a:buNone/>
             </a:pPr>
             <a:r>
@@ -2116,9 +1923,11 @@
       <p:sp>
         <p:nvSpPr>
           <p:cNvPr id="3" name="Text 0"/>
-          <p:cNvSpPr/>
+          <p:cNvSpPr>
+            <a:spLocks noGrp="1"/>
+          </p:cNvSpPr>
           <p:nvPr>
-            <p:ph idx="101" type="body" hasCustomPrompt="1"/>
+            <p:ph type="body" idx="101" hasCustomPrompt="1"/>
           </p:nvPr>
         </p:nvSpPr>
         <p:spPr>
@@ -2136,7 +1945,7 @@
           <a:bodyPr wrap="square" lIns="0" tIns="0" rIns="0" bIns="0" rtlCol="0" anchor="t"/>
           <a:lstStyle/>
           <a:p>
-            <a:pPr algn="l" indent="0" marL="0">
+            <a:pPr marL="0" indent="0" algn="l">
               <a:buNone/>
             </a:pPr>
             <a:r>
@@ -2172,7 +1981,7 @@
           <a:bodyPr wrap="square" lIns="0" tIns="0" rIns="0" bIns="0" rtlCol="0" anchor="t"/>
           <a:lstStyle/>
           <a:p>
-            <a:pPr indent="0" marL="0">
+            <a:pPr marL="0" indent="0">
               <a:buNone/>
             </a:pPr>
             <a:r>
@@ -2181,7 +1990,7 @@
                   <a:schemeClr val="bg2"/>
                 </a:solidFill>
               </a:rPr>
-              <a:t>Best Open-Source AI Project  ·  Hacktoberfest Hack Day Hamirpur x ISTE NITH  ·  Daksh</a:t>
+              <a:t>Best Open-Source AI Project  ·  Hacktoberfest Hack Day Hamirpur x ISTE NITH  ·  Daksh and Adarsh</a:t>
             </a:r>
             <a:endParaRPr lang="en-US" sz="1200" dirty="0"/>
           </a:p>
@@ -2189,14 +1998,14 @@
       </p:sp>
       <p:pic>
         <p:nvPicPr>
-          <p:cNvPr id="5" name="App screenshot" descr="The DrishtiAI page showing a camera view and two hazard warnings">    </p:cNvPr>
+          <p:cNvPr id="5" name="App screenshot" descr="The DrishtiAI page showing a camera view and two hazard warnings"/>
           <p:cNvPicPr>
             <a:picLocks noChangeAspect="1"/>
           </p:cNvPicPr>
           <p:nvPr/>
         </p:nvPicPr>
         <p:blipFill>
-          <a:blip r:embed="rId1"/>
+          <a:blip r:embed="rId3"/>
           <a:stretch>
             <a:fillRect/>
           </a:stretch>
@@ -2239,9 +2048,11 @@
       <p:sp>
         <p:nvSpPr>
           <p:cNvPr id="2" name="Text 0"/>
-          <p:cNvSpPr/>
+          <p:cNvSpPr>
+            <a:spLocks noGrp="1"/>
+          </p:cNvSpPr>
           <p:nvPr>
-            <p:ph idx="100" type="title" hasCustomPrompt="1"/>
+            <p:ph type="title" idx="100" hasCustomPrompt="1"/>
           </p:nvPr>
         </p:nvSpPr>
         <p:spPr>
@@ -2259,7 +2070,7 @@
           <a:bodyPr wrap="square" lIns="0" tIns="0" rIns="0" bIns="0" rtlCol="0" anchor="t"/>
           <a:lstStyle/>
           <a:p>
-            <a:pPr algn="l" indent="0" marL="0">
+            <a:pPr marL="0" indent="0" algn="l">
               <a:buNone/>
             </a:pPr>
             <a:r>
@@ -2317,7 +2128,7 @@
           <a:bodyPr wrap="square" lIns="0" tIns="0" rIns="0" bIns="0" rtlCol="0" anchor="t"/>
           <a:lstStyle/>
           <a:p>
-            <a:pPr indent="0" marL="0">
+            <a:pPr marL="0" indent="0">
               <a:buNone/>
             </a:pPr>
             <a:r>
@@ -2353,7 +2164,7 @@
           <a:bodyPr wrap="square" lIns="0" tIns="0" rIns="0" bIns="0" rtlCol="0" anchor="t"/>
           <a:lstStyle/>
           <a:p>
-            <a:pPr indent="0" marL="0">
+            <a:pPr marL="0" indent="0">
               <a:buNone/>
             </a:pPr>
             <a:r>
@@ -2389,7 +2200,7 @@
           <a:bodyPr wrap="square" lIns="0" tIns="0" rIns="0" bIns="0" rtlCol="0" anchor="t"/>
           <a:lstStyle/>
           <a:p>
-            <a:pPr indent="0" marL="0">
+            <a:pPr marL="0" indent="0">
               <a:buNone/>
             </a:pPr>
             <a:r>
@@ -2447,7 +2258,7 @@
           <a:bodyPr wrap="square" lIns="0" tIns="0" rIns="0" bIns="0" rtlCol="0" anchor="t"/>
           <a:lstStyle/>
           <a:p>
-            <a:pPr indent="0" marL="0">
+            <a:pPr marL="0" indent="0">
               <a:buNone/>
             </a:pPr>
             <a:r>
@@ -2483,7 +2294,7 @@
           <a:bodyPr wrap="square" lIns="0" tIns="0" rIns="0" bIns="0" rtlCol="0" anchor="t"/>
           <a:lstStyle/>
           <a:p>
-            <a:pPr indent="0" marL="0">
+            <a:pPr marL="0" indent="0">
               <a:buNone/>
             </a:pPr>
             <a:r>
@@ -2519,7 +2330,7 @@
           <a:bodyPr wrap="square" lIns="0" tIns="0" rIns="0" bIns="0" rtlCol="0" anchor="t"/>
           <a:lstStyle/>
           <a:p>
-            <a:pPr indent="0" marL="0">
+            <a:pPr marL="0" indent="0">
               <a:buNone/>
             </a:pPr>
             <a:r>
@@ -2577,7 +2388,7 @@
           <a:bodyPr wrap="square" lIns="0" tIns="0" rIns="0" bIns="0" rtlCol="0" anchor="t"/>
           <a:lstStyle/>
           <a:p>
-            <a:pPr indent="0" marL="0">
+            <a:pPr marL="0" indent="0">
               <a:buNone/>
             </a:pPr>
             <a:r>
@@ -2613,7 +2424,7 @@
           <a:bodyPr wrap="square" lIns="0" tIns="0" rIns="0" bIns="0" rtlCol="0" anchor="t"/>
           <a:lstStyle/>
           <a:p>
-            <a:pPr indent="0" marL="0">
+            <a:pPr marL="0" indent="0">
               <a:buNone/>
             </a:pPr>
             <a:r>
@@ -2649,7 +2460,7 @@
           <a:bodyPr wrap="square" lIns="0" tIns="0" rIns="0" bIns="0" rtlCol="0" anchor="t"/>
           <a:lstStyle/>
           <a:p>
-            <a:pPr indent="0" marL="0">
+            <a:pPr marL="0" indent="0">
               <a:buNone/>
             </a:pPr>
             <a:r>
@@ -2685,7 +2496,7 @@
           <a:bodyPr wrap="square" lIns="0" tIns="0" rIns="0" bIns="0" rtlCol="0" anchor="t"/>
           <a:lstStyle/>
           <a:p>
-            <a:pPr indent="0" marL="0">
+            <a:pPr marL="0" indent="0">
               <a:buNone/>
             </a:pPr>
             <a:r>
@@ -2720,7 +2531,7 @@
           </a:prstGeom>
           <a:extLst>
             <a:ext uri="{C572A759-6A51-4108-AA02-DFA0A04FC94B}">
-              <ma14:wrappingTextBoxFlag xmlns:ma14="http://schemas.microsoft.com/office/mac/drawingml/2011/main" val="0"/>
+              <ma14:wrappingTextBoxFlag xmlns:ma14="http://schemas.microsoft.com/office/mac/drawingml/2011/main" xmlns="" val="0"/>
             </a:ext>
           </a:extLst>
         </p:spPr>
@@ -2738,7 +2549,7 @@
           <a:p>
             <a:pPr algn="r"/>
             <a:fld id="{F7021451-1387-4CA6-816F-3879F97B5CBC}" type="slidenum">
-              <a:rPr b="0" lang="en-US"/>
+              <a:rPr lang="en-US" b="0"/>
               <a:t>2</a:t>
             </a:fld>
             <a:endParaRPr lang="en-US"/>
@@ -2773,9 +2584,11 @@
       <p:sp>
         <p:nvSpPr>
           <p:cNvPr id="2" name="Text 0"/>
-          <p:cNvSpPr/>
+          <p:cNvSpPr>
+            <a:spLocks noGrp="1"/>
+          </p:cNvSpPr>
           <p:nvPr>
-            <p:ph idx="100" type="title" hasCustomPrompt="1"/>
+            <p:ph type="title" idx="100" hasCustomPrompt="1"/>
           </p:nvPr>
         </p:nvSpPr>
         <p:spPr>
@@ -2793,7 +2606,7 @@
           <a:bodyPr wrap="square" lIns="0" tIns="0" rIns="0" bIns="0" rtlCol="0" anchor="t"/>
           <a:lstStyle/>
           <a:p>
-            <a:pPr algn="l" indent="0" marL="0">
+            <a:pPr marL="0" indent="0" algn="l">
               <a:buNone/>
             </a:pPr>
             <a:r>
@@ -2833,7 +2646,7 @@
           <a:bodyPr wrap="square" lIns="0" tIns="0" rIns="0" bIns="0" rtlCol="0" anchor="ctr"/>
           <a:lstStyle/>
           <a:p>
-            <a:pPr algn="ctr" indent="0" marL="0">
+            <a:pPr marL="0" indent="0" algn="ctr">
               <a:buNone/>
             </a:pPr>
             <a:r>
@@ -2869,7 +2682,7 @@
           <a:bodyPr wrap="square" lIns="0" tIns="0" rIns="0" bIns="0" rtlCol="0" anchor="t"/>
           <a:lstStyle/>
           <a:p>
-            <a:pPr indent="0" marL="0">
+            <a:pPr marL="0" indent="0">
               <a:buNone/>
             </a:pPr>
             <a:r>
@@ -2905,7 +2718,7 @@
           <a:bodyPr wrap="square" lIns="0" tIns="0" rIns="0" bIns="0" rtlCol="0" anchor="t"/>
           <a:lstStyle/>
           <a:p>
-            <a:pPr indent="0" marL="0">
+            <a:pPr marL="0" indent="0">
               <a:buNone/>
             </a:pPr>
             <a:r>
@@ -2945,7 +2758,7 @@
           <a:bodyPr wrap="square" lIns="0" tIns="0" rIns="0" bIns="0" rtlCol="0" anchor="ctr"/>
           <a:lstStyle/>
           <a:p>
-            <a:pPr algn="ctr" indent="0" marL="0">
+            <a:pPr marL="0" indent="0" algn="ctr">
               <a:buNone/>
             </a:pPr>
             <a:r>
@@ -2981,7 +2794,7 @@
           <a:bodyPr wrap="square" lIns="0" tIns="0" rIns="0" bIns="0" rtlCol="0" anchor="t"/>
           <a:lstStyle/>
           <a:p>
-            <a:pPr indent="0" marL="0">
+            <a:pPr marL="0" indent="0">
               <a:buNone/>
             </a:pPr>
             <a:r>
@@ -3017,7 +2830,7 @@
           <a:bodyPr wrap="square" lIns="0" tIns="0" rIns="0" bIns="0" rtlCol="0" anchor="t"/>
           <a:lstStyle/>
           <a:p>
-            <a:pPr indent="0" marL="0">
+            <a:pPr marL="0" indent="0">
               <a:buNone/>
             </a:pPr>
             <a:r>
@@ -3057,7 +2870,7 @@
           <a:bodyPr wrap="square" lIns="0" tIns="0" rIns="0" bIns="0" rtlCol="0" anchor="ctr"/>
           <a:lstStyle/>
           <a:p>
-            <a:pPr algn="ctr" indent="0" marL="0">
+            <a:pPr marL="0" indent="0" algn="ctr">
               <a:buNone/>
             </a:pPr>
             <a:r>
@@ -3093,7 +2906,7 @@
           <a:bodyPr wrap="square" lIns="0" tIns="0" rIns="0" bIns="0" rtlCol="0" anchor="t"/>
           <a:lstStyle/>
           <a:p>
-            <a:pPr indent="0" marL="0">
+            <a:pPr marL="0" indent="0">
               <a:buNone/>
             </a:pPr>
             <a:r>
@@ -3129,7 +2942,7 @@
           <a:bodyPr wrap="square" lIns="0" tIns="0" rIns="0" bIns="0" rtlCol="0" anchor="t"/>
           <a:lstStyle/>
           <a:p>
-            <a:pPr indent="0" marL="0">
+            <a:pPr marL="0" indent="0">
               <a:buNone/>
             </a:pPr>
             <a:r>
@@ -3146,14 +2959,14 @@
       </p:sp>
       <p:pic>
         <p:nvPicPr>
-          <p:cNvPr id="12" name="Warnings in English" descr="Two warning cards in English: open sewer manhole ahead, traffic cone on the right">    </p:cNvPr>
+          <p:cNvPr id="12" name="Warnings in English" descr="Two warning cards in English: open sewer manhole ahead, traffic cone on the right"/>
           <p:cNvPicPr>
             <a:picLocks noChangeAspect="1"/>
           </p:cNvPicPr>
           <p:nvPr/>
         </p:nvPicPr>
         <p:blipFill>
-          <a:blip r:embed="rId1"/>
+          <a:blip r:embed="rId3"/>
           <a:stretch>
             <a:fillRect/>
           </a:stretch>
@@ -3170,14 +2983,14 @@
       </p:pic>
       <p:pic>
         <p:nvPicPr>
-          <p:cNvPr id="13" name="Warnings in Hindi" descr="The same two warning cards in Hindi">    </p:cNvPr>
+          <p:cNvPr id="13" name="Warnings in Hindi" descr="The same two warning cards in Hindi"/>
           <p:cNvPicPr>
             <a:picLocks noChangeAspect="1"/>
           </p:cNvPicPr>
           <p:nvPr/>
         </p:nvPicPr>
         <p:blipFill>
-          <a:blip r:embed="rId2"/>
+          <a:blip r:embed="rId4"/>
           <a:stretch>
             <a:fillRect/>
           </a:stretch>
@@ -3212,7 +3025,7 @@
           </a:prstGeom>
           <a:extLst>
             <a:ext uri="{C572A759-6A51-4108-AA02-DFA0A04FC94B}">
-              <ma14:wrappingTextBoxFlag xmlns:ma14="http://schemas.microsoft.com/office/mac/drawingml/2011/main" val="0"/>
+              <ma14:wrappingTextBoxFlag xmlns:ma14="http://schemas.microsoft.com/office/mac/drawingml/2011/main" xmlns="" val="0"/>
             </a:ext>
           </a:extLst>
         </p:spPr>
@@ -3230,7 +3043,7 @@
           <a:p>
             <a:pPr algn="r"/>
             <a:fld id="{F7021451-1387-4CA6-816F-3879F97B5CBC}" type="slidenum">
-              <a:rPr b="0" lang="en-US"/>
+              <a:rPr lang="en-US" b="0"/>
               <a:t>3</a:t>
             </a:fld>
             <a:endParaRPr lang="en-US"/>
@@ -3265,9 +3078,11 @@
       <p:sp>
         <p:nvSpPr>
           <p:cNvPr id="2" name="Text 0"/>
-          <p:cNvSpPr/>
+          <p:cNvSpPr>
+            <a:spLocks noGrp="1"/>
+          </p:cNvSpPr>
           <p:nvPr>
-            <p:ph idx="100" type="title" hasCustomPrompt="1"/>
+            <p:ph type="title" idx="100" hasCustomPrompt="1"/>
           </p:nvPr>
         </p:nvSpPr>
         <p:spPr>
@@ -3285,7 +3100,7 @@
           <a:bodyPr wrap="square" lIns="0" tIns="0" rIns="0" bIns="0" rtlCol="0" anchor="t"/>
           <a:lstStyle/>
           <a:p>
-            <a:pPr algn="l" indent="0" marL="0">
+            <a:pPr marL="0" indent="0" algn="l">
               <a:buNone/>
             </a:pPr>
             <a:r>
@@ -3343,7 +3158,7 @@
           <a:bodyPr wrap="square" lIns="0" tIns="0" rIns="0" bIns="0" rtlCol="0" anchor="t"/>
           <a:lstStyle/>
           <a:p>
-            <a:pPr indent="0" marL="0">
+            <a:pPr marL="0" indent="0">
               <a:buNone/>
             </a:pPr>
             <a:r>
@@ -3379,7 +3194,7 @@
           <a:bodyPr wrap="square" lIns="0" tIns="0" rIns="0" bIns="0" rtlCol="0" anchor="t"/>
           <a:lstStyle/>
           <a:p>
-            <a:pPr indent="0" marL="0">
+            <a:pPr marL="0" indent="0">
               <a:buNone/>
             </a:pPr>
             <a:r>
@@ -3461,7 +3276,7 @@
           <a:bodyPr wrap="square" lIns="0" tIns="0" rIns="0" bIns="0" rtlCol="0" anchor="t"/>
           <a:lstStyle/>
           <a:p>
-            <a:pPr indent="0" marL="0">
+            <a:pPr marL="0" indent="0">
               <a:buNone/>
             </a:pPr>
             <a:r>
@@ -3497,7 +3312,7 @@
           <a:bodyPr wrap="square" lIns="0" tIns="0" rIns="0" bIns="0" rtlCol="0" anchor="t"/>
           <a:lstStyle/>
           <a:p>
-            <a:pPr indent="0" marL="0">
+            <a:pPr marL="0" indent="0">
               <a:buNone/>
             </a:pPr>
             <a:r>
@@ -3579,7 +3394,7 @@
           <a:bodyPr wrap="square" lIns="0" tIns="0" rIns="0" bIns="0" rtlCol="0" anchor="t"/>
           <a:lstStyle/>
           <a:p>
-            <a:pPr indent="0" marL="0">
+            <a:pPr marL="0" indent="0">
               <a:buNone/>
             </a:pPr>
             <a:r>
@@ -3615,7 +3430,7 @@
           <a:bodyPr wrap="square" lIns="0" tIns="0" rIns="0" bIns="0" rtlCol="0" anchor="t"/>
           <a:lstStyle/>
           <a:p>
-            <a:pPr indent="0" marL="0">
+            <a:pPr marL="0" indent="0">
               <a:buNone/>
             </a:pPr>
             <a:r>
@@ -3697,7 +3512,7 @@
           <a:bodyPr wrap="square" lIns="0" tIns="0" rIns="0" bIns="0" rtlCol="0" anchor="t"/>
           <a:lstStyle/>
           <a:p>
-            <a:pPr indent="0" marL="0">
+            <a:pPr marL="0" indent="0">
               <a:buNone/>
             </a:pPr>
             <a:r>
@@ -3733,7 +3548,7 @@
           <a:bodyPr wrap="square" lIns="0" tIns="0" rIns="0" bIns="0" rtlCol="0" anchor="t"/>
           <a:lstStyle/>
           <a:p>
-            <a:pPr indent="0" marL="0">
+            <a:pPr marL="0" indent="0">
               <a:buNone/>
             </a:pPr>
             <a:r>
@@ -3815,7 +3630,7 @@
           <a:bodyPr wrap="square" lIns="0" tIns="0" rIns="0" bIns="0" rtlCol="0" anchor="t"/>
           <a:lstStyle/>
           <a:p>
-            <a:pPr indent="0" marL="0">
+            <a:pPr marL="0" indent="0">
               <a:buNone/>
             </a:pPr>
             <a:r>
@@ -3851,7 +3666,7 @@
           <a:bodyPr wrap="square" lIns="0" tIns="0" rIns="0" bIns="0" rtlCol="0" anchor="t"/>
           <a:lstStyle/>
           <a:p>
-            <a:pPr indent="0" marL="0">
+            <a:pPr marL="0" indent="0">
               <a:buNone/>
             </a:pPr>
             <a:r>
@@ -3933,7 +3748,7 @@
           <a:bodyPr wrap="square" lIns="0" tIns="0" rIns="0" bIns="0" rtlCol="0" anchor="t"/>
           <a:lstStyle/>
           <a:p>
-            <a:pPr indent="0" marL="0">
+            <a:pPr marL="0" indent="0">
               <a:buNone/>
             </a:pPr>
             <a:r>
@@ -3969,7 +3784,7 @@
           <a:bodyPr wrap="square" lIns="0" tIns="0" rIns="0" bIns="0" rtlCol="0" anchor="t"/>
           <a:lstStyle/>
           <a:p>
-            <a:pPr indent="0" marL="0">
+            <a:pPr marL="0" indent="0">
               <a:buNone/>
             </a:pPr>
             <a:r>
@@ -4027,7 +3842,7 @@
           <a:bodyPr wrap="square" lIns="0" tIns="0" rIns="0" bIns="0" rtlCol="0" anchor="t"/>
           <a:lstStyle/>
           <a:p>
-            <a:pPr indent="0" marL="0">
+            <a:pPr marL="0" indent="0">
               <a:buNone/>
             </a:pPr>
             <a:r>
@@ -4063,7 +3878,7 @@
           <a:bodyPr wrap="square" lIns="0" tIns="0" rIns="0" bIns="0" rtlCol="0" anchor="t"/>
           <a:lstStyle/>
           <a:p>
-            <a:pPr indent="0" marL="0">
+            <a:pPr marL="0" indent="0">
               <a:buNone/>
             </a:pPr>
             <a:r>
@@ -4121,7 +3936,7 @@
           <a:bodyPr wrap="square" lIns="0" tIns="0" rIns="0" bIns="0" rtlCol="0" anchor="t"/>
           <a:lstStyle/>
           <a:p>
-            <a:pPr indent="0" marL="0">
+            <a:pPr marL="0" indent="0">
               <a:buNone/>
             </a:pPr>
             <a:r>
@@ -4157,7 +3972,7 @@
           <a:bodyPr wrap="square" lIns="0" tIns="0" rIns="0" bIns="0" rtlCol="0" anchor="t"/>
           <a:lstStyle/>
           <a:p>
-            <a:pPr indent="0" marL="0">
+            <a:pPr marL="0" indent="0">
               <a:buNone/>
             </a:pPr>
             <a:r>
@@ -4215,7 +4030,7 @@
           <a:bodyPr wrap="square" lIns="0" tIns="0" rIns="0" bIns="0" rtlCol="0" anchor="t"/>
           <a:lstStyle/>
           <a:p>
-            <a:pPr indent="0" marL="0">
+            <a:pPr marL="0" indent="0">
               <a:buNone/>
             </a:pPr>
             <a:r>
@@ -4251,7 +4066,7 @@
           <a:bodyPr wrap="square" lIns="0" tIns="0" rIns="0" bIns="0" rtlCol="0" anchor="t"/>
           <a:lstStyle/>
           <a:p>
-            <a:pPr indent="0" marL="0">
+            <a:pPr marL="0" indent="0">
               <a:buNone/>
             </a:pPr>
             <a:r>
@@ -4309,7 +4124,7 @@
           <a:bodyPr wrap="square" lIns="0" tIns="0" rIns="0" bIns="0" rtlCol="0" anchor="t"/>
           <a:lstStyle/>
           <a:p>
-            <a:pPr indent="0" marL="0">
+            <a:pPr marL="0" indent="0">
               <a:buNone/>
             </a:pPr>
             <a:r>
@@ -4345,7 +4160,7 @@
           <a:bodyPr wrap="square" lIns="0" tIns="0" rIns="0" bIns="0" rtlCol="0" anchor="t"/>
           <a:lstStyle/>
           <a:p>
-            <a:pPr indent="0" marL="0">
+            <a:pPr marL="0" indent="0">
               <a:buNone/>
             </a:pPr>
             <a:r>
@@ -4381,7 +4196,7 @@
           <a:bodyPr wrap="square" lIns="0" tIns="0" rIns="0" bIns="0" rtlCol="0" anchor="t"/>
           <a:lstStyle/>
           <a:p>
-            <a:pPr indent="0" marL="0">
+            <a:pPr marL="0" indent="0">
               <a:buNone/>
             </a:pPr>
             <a:r>
@@ -4398,7 +4213,7 @@
       </p:sp>
       <p:sp>
         <p:nvSpPr>
-          <p:cNvPr id="25" name="Slide Number Placeholder 0"/>
+          <p:cNvPr id="39" name="Slide Number Placeholder 0"/>
           <p:cNvSpPr>
             <a:spLocks noGrp="1"/>
           </p:cNvSpPr>
@@ -4416,7 +4231,7 @@
           </a:prstGeom>
           <a:extLst>
             <a:ext uri="{C572A759-6A51-4108-AA02-DFA0A04FC94B}">
-              <ma14:wrappingTextBoxFlag xmlns:ma14="http://schemas.microsoft.com/office/mac/drawingml/2011/main" val="0"/>
+              <ma14:wrappingTextBoxFlag xmlns:ma14="http://schemas.microsoft.com/office/mac/drawingml/2011/main" xmlns="" val="0"/>
             </a:ext>
           </a:extLst>
         </p:spPr>
@@ -4434,7 +4249,7 @@
           <a:p>
             <a:pPr algn="r"/>
             <a:fld id="{F7021451-1387-4CA6-816F-3879F97B5CBC}" type="slidenum">
-              <a:rPr b="0" lang="en-US"/>
+              <a:rPr lang="en-US" b="0"/>
               <a:t>4</a:t>
             </a:fld>
             <a:endParaRPr lang="en-US"/>
@@ -4469,9 +4284,11 @@
       <p:sp>
         <p:nvSpPr>
           <p:cNvPr id="2" name="Text 0"/>
-          <p:cNvSpPr/>
+          <p:cNvSpPr>
+            <a:spLocks noGrp="1"/>
+          </p:cNvSpPr>
           <p:nvPr>
-            <p:ph idx="100" type="title" hasCustomPrompt="1"/>
+            <p:ph type="title" idx="100" hasCustomPrompt="1"/>
           </p:nvPr>
         </p:nvSpPr>
         <p:spPr>
@@ -4489,7 +4306,7 @@
           <a:bodyPr wrap="square" lIns="0" tIns="0" rIns="0" bIns="0" rtlCol="0" anchor="t"/>
           <a:lstStyle/>
           <a:p>
-            <a:pPr algn="l" indent="0" marL="0">
+            <a:pPr marL="0" indent="0" algn="l">
               <a:buNone/>
             </a:pPr>
             <a:r>
@@ -4506,7 +4323,7 @@
       </p:sp>
       <p:graphicFrame>
         <p:nvGraphicFramePr>
-          <p:cNvPr id="3" name="Before and after chart" descr=""/>
+          <p:cNvPr id="3" name="Before and after chart"/>
           <p:cNvGraphicFramePr/>
           <p:nvPr/>
         </p:nvGraphicFramePr>
@@ -4514,9 +4331,9 @@
           <a:off x="457200" y="1188720"/>
           <a:ext cx="5212080" cy="2926080"/>
         </p:xfrm>
-        <a:graphic xmlns:a="http://schemas.openxmlformats.org/drawingml/2006/main">
+        <a:graphic>
           <a:graphicData uri="http://schemas.openxmlformats.org/drawingml/2006/chart">
-            <c:chart xmlns:c="http://schemas.openxmlformats.org/drawingml/2006/chart" r:id="rId1"/>
+            <c:chart xmlns:c="http://schemas.openxmlformats.org/drawingml/2006/chart" xmlns:r="http://schemas.openxmlformats.org/officeDocument/2006/relationships" r:id="rId3"/>
           </a:graphicData>
         </a:graphic>
       </p:graphicFrame>
@@ -4563,7 +4380,7 @@
           <a:bodyPr wrap="square" lIns="0" tIns="0" rIns="0" bIns="0" rtlCol="0" anchor="t"/>
           <a:lstStyle/>
           <a:p>
-            <a:pPr indent="0" marL="0">
+            <a:pPr marL="0" indent="0">
               <a:buNone/>
             </a:pPr>
             <a:r>
@@ -4599,7 +4416,7 @@
           <a:bodyPr wrap="square" lIns="0" tIns="0" rIns="0" bIns="0" rtlCol="0" anchor="t"/>
           <a:lstStyle/>
           <a:p>
-            <a:pPr indent="0" marL="0">
+            <a:pPr marL="0" indent="0">
               <a:buNone/>
             </a:pPr>
             <a:r>
@@ -4657,7 +4474,7 @@
           <a:bodyPr wrap="square" lIns="0" tIns="0" rIns="0" bIns="0" rtlCol="0" anchor="t"/>
           <a:lstStyle/>
           <a:p>
-            <a:pPr indent="0" marL="0">
+            <a:pPr marL="0" indent="0">
               <a:buNone/>
             </a:pPr>
             <a:r>
@@ -4693,7 +4510,7 @@
           <a:bodyPr wrap="square" lIns="0" tIns="0" rIns="0" bIns="0" rtlCol="0" anchor="t"/>
           <a:lstStyle/>
           <a:p>
-            <a:pPr indent="0" marL="0">
+            <a:pPr marL="0" indent="0">
               <a:buNone/>
             </a:pPr>
             <a:r>
@@ -4729,7 +4546,7 @@
           <a:bodyPr wrap="square" lIns="0" tIns="0" rIns="0" bIns="0" rtlCol="0" anchor="t"/>
           <a:lstStyle/>
           <a:p>
-            <a:pPr indent="0" marL="0">
+            <a:pPr marL="0" indent="0">
               <a:buNone/>
             </a:pPr>
             <a:r>
@@ -4764,7 +4581,7 @@
           </a:prstGeom>
           <a:extLst>
             <a:ext uri="{C572A759-6A51-4108-AA02-DFA0A04FC94B}">
-              <ma14:wrappingTextBoxFlag xmlns:ma14="http://schemas.microsoft.com/office/mac/drawingml/2011/main" val="0"/>
+              <ma14:wrappingTextBoxFlag xmlns:ma14="http://schemas.microsoft.com/office/mac/drawingml/2011/main" xmlns="" val="0"/>
             </a:ext>
           </a:extLst>
         </p:spPr>
@@ -4782,7 +4599,7 @@
           <a:p>
             <a:pPr algn="r"/>
             <a:fld id="{F7021451-1387-4CA6-816F-3879F97B5CBC}" type="slidenum">
-              <a:rPr b="0" lang="en-US"/>
+              <a:rPr lang="en-US" b="0"/>
               <a:t>5</a:t>
             </a:fld>
             <a:endParaRPr lang="en-US"/>
@@ -4817,9 +4634,11 @@
       <p:sp>
         <p:nvSpPr>
           <p:cNvPr id="2" name="Text 0"/>
-          <p:cNvSpPr/>
+          <p:cNvSpPr>
+            <a:spLocks noGrp="1"/>
+          </p:cNvSpPr>
           <p:nvPr>
-            <p:ph idx="100" type="title" hasCustomPrompt="1"/>
+            <p:ph type="title" idx="100" hasCustomPrompt="1"/>
           </p:nvPr>
         </p:nvSpPr>
         <p:spPr>
@@ -4837,7 +4656,7 @@
           <a:bodyPr wrap="square" lIns="0" tIns="0" rIns="0" bIns="0" rtlCol="0" anchor="t"/>
           <a:lstStyle/>
           <a:p>
-            <a:pPr algn="l" indent="0" marL="0">
+            <a:pPr marL="0" indent="0" algn="l">
               <a:buNone/>
             </a:pPr>
             <a:r>
@@ -4895,7 +4714,7 @@
           <a:bodyPr wrap="square" lIns="0" tIns="0" rIns="0" bIns="0" rtlCol="0" anchor="t"/>
           <a:lstStyle/>
           <a:p>
-            <a:pPr indent="0" marL="0">
+            <a:pPr marL="0" indent="0">
               <a:buNone/>
             </a:pPr>
             <a:r>
@@ -4931,7 +4750,7 @@
           <a:bodyPr wrap="square" lIns="0" tIns="0" rIns="0" bIns="0" rtlCol="0" anchor="t"/>
           <a:lstStyle/>
           <a:p>
-            <a:pPr indent="0" marL="0">
+            <a:pPr marL="0" indent="0">
               <a:buNone/>
             </a:pPr>
             <a:r>
@@ -4971,7 +4790,7 @@
           <a:bodyPr wrap="square" lIns="0" tIns="0" rIns="0" bIns="0" rtlCol="0" anchor="ctr"/>
           <a:lstStyle/>
           <a:p>
-            <a:pPr algn="ctr" indent="0" marL="0">
+            <a:pPr marL="0" indent="0" algn="ctr">
               <a:buNone/>
             </a:pPr>
             <a:r>
@@ -5029,7 +4848,7 @@
           <a:bodyPr wrap="square" lIns="0" tIns="0" rIns="0" bIns="0" rtlCol="0" anchor="t"/>
           <a:lstStyle/>
           <a:p>
-            <a:pPr indent="0" marL="0">
+            <a:pPr marL="0" indent="0">
               <a:buNone/>
             </a:pPr>
             <a:r>
@@ -5065,7 +4884,7 @@
           <a:bodyPr wrap="square" lIns="0" tIns="0" rIns="0" bIns="0" rtlCol="0" anchor="t"/>
           <a:lstStyle/>
           <a:p>
-            <a:pPr indent="0" marL="0">
+            <a:pPr marL="0" indent="0">
               <a:buNone/>
             </a:pPr>
             <a:r>
@@ -5123,7 +4942,7 @@
           <a:bodyPr wrap="square" lIns="0" tIns="0" rIns="0" bIns="0" rtlCol="0" anchor="t"/>
           <a:lstStyle/>
           <a:p>
-            <a:pPr indent="0" marL="0">
+            <a:pPr marL="0" indent="0">
               <a:buNone/>
             </a:pPr>
             <a:r>
@@ -5159,7 +4978,7 @@
           <a:bodyPr wrap="square" lIns="0" tIns="0" rIns="0" bIns="0" rtlCol="0" anchor="t"/>
           <a:lstStyle/>
           <a:p>
-            <a:pPr indent="0" marL="0">
+            <a:pPr marL="0" indent="0">
               <a:buNone/>
             </a:pPr>
             <a:r>
@@ -5199,7 +5018,7 @@
           <a:bodyPr wrap="square" lIns="0" tIns="0" rIns="0" bIns="0" rtlCol="0" anchor="ctr"/>
           <a:lstStyle/>
           <a:p>
-            <a:pPr algn="ctr" indent="0" marL="0">
+            <a:pPr marL="0" indent="0" algn="ctr">
               <a:buNone/>
             </a:pPr>
             <a:r>
@@ -5257,7 +5076,7 @@
           <a:bodyPr wrap="square" lIns="0" tIns="0" rIns="0" bIns="0" rtlCol="0" anchor="t"/>
           <a:lstStyle/>
           <a:p>
-            <a:pPr indent="0" marL="0">
+            <a:pPr marL="0" indent="0">
               <a:buNone/>
             </a:pPr>
             <a:r>
@@ -5293,7 +5112,7 @@
           <a:bodyPr wrap="square" lIns="0" tIns="0" rIns="0" bIns="0" rtlCol="0" anchor="t"/>
           <a:lstStyle/>
           <a:p>
-            <a:pPr indent="0" marL="0">
+            <a:pPr marL="0" indent="0">
               <a:buNone/>
             </a:pPr>
             <a:r>
@@ -5351,7 +5170,7 @@
           <a:bodyPr wrap="square" lIns="0" tIns="0" rIns="0" bIns="0" rtlCol="0" anchor="t"/>
           <a:lstStyle/>
           <a:p>
-            <a:pPr indent="0" marL="0">
+            <a:pPr marL="0" indent="0">
               <a:buNone/>
             </a:pPr>
             <a:r>
@@ -5387,7 +5206,7 @@
           <a:bodyPr wrap="square" lIns="0" tIns="0" rIns="0" bIns="0" rtlCol="0" anchor="t"/>
           <a:lstStyle/>
           <a:p>
-            <a:pPr indent="0" marL="0">
+            <a:pPr marL="0" indent="0">
               <a:buNone/>
             </a:pPr>
             <a:r>
@@ -5427,7 +5246,7 @@
           <a:bodyPr wrap="square" lIns="0" tIns="0" rIns="0" bIns="0" rtlCol="0" anchor="ctr"/>
           <a:lstStyle/>
           <a:p>
-            <a:pPr algn="ctr" indent="0" marL="0">
+            <a:pPr marL="0" indent="0" algn="ctr">
               <a:buNone/>
             </a:pPr>
             <a:r>
@@ -5485,7 +5304,7 @@
           <a:bodyPr wrap="square" lIns="0" tIns="0" rIns="0" bIns="0" rtlCol="0" anchor="t"/>
           <a:lstStyle/>
           <a:p>
-            <a:pPr indent="0" marL="0">
+            <a:pPr marL="0" indent="0">
               <a:buNone/>
             </a:pPr>
             <a:r>
@@ -5521,7 +5340,7 @@
           <a:bodyPr wrap="square" lIns="0" tIns="0" rIns="0" bIns="0" rtlCol="0" anchor="t"/>
           <a:lstStyle/>
           <a:p>
-            <a:pPr indent="0" marL="0">
+            <a:pPr marL="0" indent="0">
               <a:buNone/>
             </a:pPr>
             <a:r>
@@ -5556,7 +5375,7 @@
           </a:prstGeom>
           <a:extLst>
             <a:ext uri="{C572A759-6A51-4108-AA02-DFA0A04FC94B}">
-              <ma14:wrappingTextBoxFlag xmlns:ma14="http://schemas.microsoft.com/office/mac/drawingml/2011/main" val="0"/>
+              <ma14:wrappingTextBoxFlag xmlns:ma14="http://schemas.microsoft.com/office/mac/drawingml/2011/main" xmlns="" val="0"/>
             </a:ext>
           </a:extLst>
         </p:spPr>
@@ -5574,7 +5393,7 @@
           <a:p>
             <a:pPr algn="r"/>
             <a:fld id="{F7021451-1387-4CA6-816F-3879F97B5CBC}" type="slidenum">
-              <a:rPr b="0" lang="en-US"/>
+              <a:rPr lang="en-US" b="0"/>
               <a:t>6</a:t>
             </a:fld>
             <a:endParaRPr lang="en-US"/>
@@ -5609,9 +5428,11 @@
       <p:sp>
         <p:nvSpPr>
           <p:cNvPr id="2" name="Text 0"/>
-          <p:cNvSpPr/>
+          <p:cNvSpPr>
+            <a:spLocks noGrp="1"/>
+          </p:cNvSpPr>
           <p:nvPr>
-            <p:ph idx="100" type="title" hasCustomPrompt="1"/>
+            <p:ph type="title" idx="100" hasCustomPrompt="1"/>
           </p:nvPr>
         </p:nvSpPr>
         <p:spPr>
@@ -5629,7 +5450,7 @@
           <a:bodyPr wrap="square" lIns="0" tIns="0" rIns="0" bIns="0" rtlCol="0" anchor="t"/>
           <a:lstStyle/>
           <a:p>
-            <a:pPr algn="l" indent="0" marL="0">
+            <a:pPr marL="0" indent="0" algn="l">
               <a:buNone/>
             </a:pPr>
             <a:r>
@@ -5687,7 +5508,7 @@
           <a:bodyPr wrap="square" lIns="0" tIns="0" rIns="0" bIns="0" rtlCol="0" anchor="t"/>
           <a:lstStyle/>
           <a:p>
-            <a:pPr indent="0" marL="0">
+            <a:pPr marL="0" indent="0">
               <a:buNone/>
             </a:pPr>
             <a:r>
@@ -5839,7 +5660,7 @@
           <a:bodyPr wrap="square" lIns="0" tIns="0" rIns="0" bIns="0" rtlCol="0" anchor="t"/>
           <a:lstStyle/>
           <a:p>
-            <a:pPr indent="0" marL="0">
+            <a:pPr marL="0" indent="0">
               <a:buNone/>
             </a:pPr>
             <a:r>
@@ -5991,7 +5812,7 @@
           <a:bodyPr wrap="square" lIns="0" tIns="0" rIns="0" bIns="0" rtlCol="0" anchor="t"/>
           <a:lstStyle/>
           <a:p>
-            <a:pPr indent="0" marL="0">
+            <a:pPr marL="0" indent="0">
               <a:buNone/>
             </a:pPr>
             <a:r>
@@ -6027,7 +5848,7 @@
           <a:bodyPr wrap="square" lIns="0" tIns="0" rIns="0" bIns="0" rtlCol="0" anchor="t"/>
           <a:lstStyle/>
           <a:p>
-            <a:pPr indent="0" marL="0">
+            <a:pPr marL="0" indent="0">
               <a:buNone/>
             </a:pPr>
             <a:r>
@@ -6062,7 +5883,7 @@
           </a:prstGeom>
           <a:extLst>
             <a:ext uri="{C572A759-6A51-4108-AA02-DFA0A04FC94B}">
-              <ma14:wrappingTextBoxFlag xmlns:ma14="http://schemas.microsoft.com/office/mac/drawingml/2011/main" val="0"/>
+              <ma14:wrappingTextBoxFlag xmlns:ma14="http://schemas.microsoft.com/office/mac/drawingml/2011/main" xmlns="" val="0"/>
             </a:ext>
           </a:extLst>
         </p:spPr>
@@ -6080,7 +5901,7 @@
           <a:p>
             <a:pPr algn="r"/>
             <a:fld id="{F7021451-1387-4CA6-816F-3879F97B5CBC}" type="slidenum">
-              <a:rPr b="0" lang="en-US"/>
+              <a:rPr lang="en-US" b="0"/>
               <a:t>7</a:t>
             </a:fld>
             <a:endParaRPr lang="en-US"/>
@@ -6388,4 +6209,299 @@
     </a:ext>
   </a:extLst>
 </a:theme>
+</file>
+
+<file path=ppt/theme/theme2.xml><?xml version="1.0" encoding="utf-8"?>
+<a:theme xmlns:a="http://schemas.openxmlformats.org/drawingml/2006/main" name="Office Theme">
+  <a:themeElements>
+    <a:clrScheme name="Office">
+      <a:dk1>
+        <a:sysClr val="windowText" lastClr="000000"/>
+      </a:dk1>
+      <a:lt1>
+        <a:sysClr val="window" lastClr="FFFFFF"/>
+      </a:lt1>
+      <a:dk2>
+        <a:srgbClr val="44546A"/>
+      </a:dk2>
+      <a:lt2>
+        <a:srgbClr val="E7E6E6"/>
+      </a:lt2>
+      <a:accent1>
+        <a:srgbClr val="4472C4"/>
+      </a:accent1>
+      <a:accent2>
+        <a:srgbClr val="ED7D31"/>
+      </a:accent2>
+      <a:accent3>
+        <a:srgbClr val="A5A5A5"/>
+      </a:accent3>
+      <a:accent4>
+        <a:srgbClr val="FFC000"/>
+      </a:accent4>
+      <a:accent5>
+        <a:srgbClr val="5B9BD5"/>
+      </a:accent5>
+      <a:accent6>
+        <a:srgbClr val="70AD47"/>
+      </a:accent6>
+      <a:hlink>
+        <a:srgbClr val="0563C1"/>
+      </a:hlink>
+      <a:folHlink>
+        <a:srgbClr val="954F72"/>
+      </a:folHlink>
+    </a:clrScheme>
+    <a:fontScheme name="Office">
+      <a:majorFont>
+        <a:latin typeface="Calibri Light" panose="020F0302020204030204"/>
+        <a:ea typeface=""/>
+        <a:cs typeface=""/>
+        <a:font script="Jpan" typeface="游ゴシック Light"/>
+        <a:font script="Hang" typeface="맑은 고딕"/>
+        <a:font script="Hans" typeface="等线 Light"/>
+        <a:font script="Hant" typeface="新細明體"/>
+        <a:font script="Arab" typeface="Times New Roman"/>
+        <a:font script="Hebr" typeface="Times New Roman"/>
+        <a:font script="Thai" typeface="Angsana New"/>
+        <a:font script="Ethi" typeface="Nyala"/>
+        <a:font script="Beng" typeface="Vrinda"/>
+        <a:font script="Gujr" typeface="Shruti"/>
+        <a:font script="Khmr" typeface="MoolBoran"/>
+        <a:font script="Knda" typeface="Tunga"/>
+        <a:font script="Guru" typeface="Raavi"/>
+        <a:font script="Cans" typeface="Euphemia"/>
+        <a:font script="Cher" typeface="Plantagenet Cherokee"/>
+        <a:font script="Yiii" typeface="Microsoft Yi Baiti"/>
+        <a:font script="Tibt" typeface="Microsoft Himalaya"/>
+        <a:font script="Thaa" typeface="MV Boli"/>
+        <a:font script="Deva" typeface="Mangal"/>
+        <a:font script="Telu" typeface="Gautami"/>
+        <a:font script="Taml" typeface="Latha"/>
+        <a:font script="Syrc" typeface="Estrangelo Edessa"/>
+        <a:font script="Orya" typeface="Kalinga"/>
+        <a:font script="Mlym" typeface="Kartika"/>
+        <a:font script="Laoo" typeface="DokChampa"/>
+        <a:font script="Sinh" typeface="Iskoola Pota"/>
+        <a:font script="Mong" typeface="Mongolian Baiti"/>
+        <a:font script="Viet" typeface="Times New Roman"/>
+        <a:font script="Uigh" typeface="Microsoft Uighur"/>
+        <a:font script="Geor" typeface="Sylfaen"/>
+        <a:font script="Armn" typeface="Arial"/>
+        <a:font script="Bugi" typeface="Leelawadee UI"/>
+        <a:font script="Bopo" typeface="Microsoft JhengHei"/>
+        <a:font script="Java" typeface="Javanese Text"/>
+        <a:font script="Lisu" typeface="Segoe UI"/>
+        <a:font script="Mymr" typeface="Myanmar Text"/>
+        <a:font script="Nkoo" typeface="Ebrima"/>
+        <a:font script="Olck" typeface="Nirmala UI"/>
+        <a:font script="Osma" typeface="Ebrima"/>
+        <a:font script="Phag" typeface="Phagspa"/>
+        <a:font script="Syrn" typeface="Estrangelo Edessa"/>
+        <a:font script="Syrj" typeface="Estrangelo Edessa"/>
+        <a:font script="Syre" typeface="Estrangelo Edessa"/>
+        <a:font script="Sora" typeface="Nirmala UI"/>
+        <a:font script="Tale" typeface="Microsoft Tai Le"/>
+        <a:font script="Talu" typeface="Microsoft New Tai Lue"/>
+        <a:font script="Tfng" typeface="Ebrima"/>
+      </a:majorFont>
+      <a:minorFont>
+        <a:latin typeface="Calibri" panose="020F0502020204030204"/>
+        <a:ea typeface=""/>
+        <a:cs typeface=""/>
+        <a:font script="Jpan" typeface="游ゴシック"/>
+        <a:font script="Hang" typeface="맑은 고딕"/>
+        <a:font script="Hans" typeface="等线"/>
+        <a:font script="Hant" typeface="新細明體"/>
+        <a:font script="Arab" typeface="Arial"/>
+        <a:font script="Hebr" typeface="Arial"/>
+        <a:font script="Thai" typeface="Cordia New"/>
+        <a:font script="Ethi" typeface="Nyala"/>
+        <a:font script="Beng" typeface="Vrinda"/>
+        <a:font script="Gujr" typeface="Shruti"/>
+        <a:font script="Khmr" typeface="DaunPenh"/>
+        <a:font script="Knda" typeface="Tunga"/>
+        <a:font script="Guru" typeface="Raavi"/>
+        <a:font script="Cans" typeface="Euphemia"/>
+        <a:font script="Cher" typeface="Plantagenet Cherokee"/>
+        <a:font script="Yiii" typeface="Microsoft Yi Baiti"/>
+        <a:font script="Tibt" typeface="Microsoft Himalaya"/>
+        <a:font script="Thaa" typeface="MV Boli"/>
+        <a:font script="Deva" typeface="Mangal"/>
+        <a:font script="Telu" typeface="Gautami"/>
+        <a:font script="Taml" typeface="Latha"/>
+        <a:font script="Syrc" typeface="Estrangelo Edessa"/>
+        <a:font script="Orya" typeface="Kalinga"/>
+        <a:font script="Mlym" typeface="Kartika"/>
+        <a:font script="Laoo" typeface="DokChampa"/>
+        <a:font script="Sinh" typeface="Iskoola Pota"/>
+        <a:font script="Mong" typeface="Mongolian Baiti"/>
+        <a:font script="Viet" typeface="Arial"/>
+        <a:font script="Uigh" typeface="Microsoft Uighur"/>
+        <a:font script="Geor" typeface="Sylfaen"/>
+        <a:font script="Armn" typeface="Arial"/>
+        <a:font script="Bugi" typeface="Leelawadee UI"/>
+        <a:font script="Bopo" typeface="Microsoft JhengHei"/>
+        <a:font script="Java" typeface="Javanese Text"/>
+        <a:font script="Lisu" typeface="Segoe UI"/>
+        <a:font script="Mymr" typeface="Myanmar Text"/>
+        <a:font script="Nkoo" typeface="Ebrima"/>
+        <a:font script="Olck" typeface="Nirmala UI"/>
+        <a:font script="Osma" typeface="Ebrima"/>
+        <a:font script="Phag" typeface="Phagspa"/>
+        <a:font script="Syrn" typeface="Estrangelo Edessa"/>
+        <a:font script="Syrj" typeface="Estrangelo Edessa"/>
+        <a:font script="Syre" typeface="Estrangelo Edessa"/>
+        <a:font script="Sora" typeface="Nirmala UI"/>
+        <a:font script="Tale" typeface="Microsoft Tai Le"/>
+        <a:font script="Talu" typeface="Microsoft New Tai Lue"/>
+        <a:font script="Tfng" typeface="Ebrima"/>
+      </a:minorFont>
+    </a:fontScheme>
+    <a:fmtScheme name="Office">
+      <a:fillStyleLst>
+        <a:solidFill>
+          <a:schemeClr val="phClr"/>
+        </a:solidFill>
+        <a:gradFill rotWithShape="1">
+          <a:gsLst>
+            <a:gs pos="0">
+              <a:schemeClr val="phClr">
+                <a:lumMod val="110000"/>
+                <a:satMod val="105000"/>
+                <a:tint val="67000"/>
+              </a:schemeClr>
+            </a:gs>
+            <a:gs pos="50000">
+              <a:schemeClr val="phClr">
+                <a:lumMod val="105000"/>
+                <a:satMod val="103000"/>
+                <a:tint val="73000"/>
+              </a:schemeClr>
+            </a:gs>
+            <a:gs pos="100000">
+              <a:schemeClr val="phClr">
+                <a:lumMod val="105000"/>
+                <a:satMod val="109000"/>
+                <a:tint val="81000"/>
+              </a:schemeClr>
+            </a:gs>
+          </a:gsLst>
+          <a:lin ang="5400000" scaled="0"/>
+        </a:gradFill>
+        <a:gradFill rotWithShape="1">
+          <a:gsLst>
+            <a:gs pos="0">
+              <a:schemeClr val="phClr">
+                <a:satMod val="103000"/>
+                <a:lumMod val="102000"/>
+                <a:tint val="94000"/>
+              </a:schemeClr>
+            </a:gs>
+            <a:gs pos="50000">
+              <a:schemeClr val="phClr">
+                <a:satMod val="110000"/>
+                <a:lumMod val="100000"/>
+                <a:shade val="100000"/>
+              </a:schemeClr>
+            </a:gs>
+            <a:gs pos="100000">
+              <a:schemeClr val="phClr">
+                <a:lumMod val="99000"/>
+                <a:satMod val="120000"/>
+                <a:shade val="78000"/>
+              </a:schemeClr>
+            </a:gs>
+          </a:gsLst>
+          <a:lin ang="5400000" scaled="0"/>
+        </a:gradFill>
+      </a:fillStyleLst>
+      <a:lnStyleLst>
+        <a:ln w="6350" cap="flat" cmpd="sng" algn="ctr">
+          <a:solidFill>
+            <a:schemeClr val="phClr"/>
+          </a:solidFill>
+          <a:prstDash val="solid"/>
+          <a:miter lim="800000"/>
+        </a:ln>
+        <a:ln w="12700" cap="flat" cmpd="sng" algn="ctr">
+          <a:solidFill>
+            <a:schemeClr val="phClr"/>
+          </a:solidFill>
+          <a:prstDash val="solid"/>
+          <a:miter lim="800000"/>
+        </a:ln>
+        <a:ln w="19050" cap="flat" cmpd="sng" algn="ctr">
+          <a:solidFill>
+            <a:schemeClr val="phClr"/>
+          </a:solidFill>
+          <a:prstDash val="solid"/>
+          <a:miter lim="800000"/>
+        </a:ln>
+      </a:lnStyleLst>
+      <a:effectStyleLst>
+        <a:effectStyle>
+          <a:effectLst/>
+        </a:effectStyle>
+        <a:effectStyle>
+          <a:effectLst/>
+        </a:effectStyle>
+        <a:effectStyle>
+          <a:effectLst>
+            <a:outerShdw blurRad="57150" dist="19050" dir="5400000" algn="ctr" rotWithShape="0">
+              <a:srgbClr val="000000">
+                <a:alpha val="63000"/>
+              </a:srgbClr>
+            </a:outerShdw>
+          </a:effectLst>
+        </a:effectStyle>
+      </a:effectStyleLst>
+      <a:bgFillStyleLst>
+        <a:solidFill>
+          <a:schemeClr val="phClr"/>
+        </a:solidFill>
+        <a:solidFill>
+          <a:schemeClr val="phClr">
+            <a:tint val="95000"/>
+            <a:satMod val="170000"/>
+          </a:schemeClr>
+        </a:solidFill>
+        <a:gradFill rotWithShape="1">
+          <a:gsLst>
+            <a:gs pos="0">
+              <a:schemeClr val="phClr">
+                <a:tint val="93000"/>
+                <a:satMod val="150000"/>
+                <a:shade val="98000"/>
+                <a:lumMod val="102000"/>
+              </a:schemeClr>
+            </a:gs>
+            <a:gs pos="50000">
+              <a:schemeClr val="phClr">
+                <a:tint val="98000"/>
+                <a:satMod val="130000"/>
+                <a:shade val="90000"/>
+                <a:lumMod val="103000"/>
+              </a:schemeClr>
+            </a:gs>
+            <a:gs pos="100000">
+              <a:schemeClr val="phClr">
+                <a:shade val="63000"/>
+                <a:satMod val="120000"/>
+              </a:schemeClr>
+            </a:gs>
+          </a:gsLst>
+          <a:lin ang="5400000" scaled="0"/>
+        </a:gradFill>
+      </a:bgFillStyleLst>
+    </a:fmtScheme>
+  </a:themeElements>
+  <a:objectDefaults/>
+  <a:extraClrSchemeLst/>
+  <a:extLst>
+    <a:ext uri="{05A4C25C-085E-4340-85A3-A5531E510DB2}">
+      <thm15:themeFamily xmlns:thm15="http://schemas.microsoft.com/office/thememl/2012/main" name="Office Theme" id="{62F939B6-93AF-4DB8-9C6B-D6C7DFDC589F}" vid="{4A3C46E8-61CC-4603-A589-7422A47A8E4A}"/>
+    </a:ext>
+  </a:extLst>
+</a:theme>
 </file>
</xml_diff>